<commit_message>
feat: add application and market watch workflows
</commit_message>
<xml_diff>
--- a/pitch-deck/capital-pitch-deck.pptx
+++ b/pitch-deck/capital-pitch-deck.pptx
@@ -11,6 +11,7 @@
     <p:sldId id="259" r:id="rId5"/>
     <p:sldId id="260" r:id="rId6"/>
     <p:sldId id="261" r:id="rId7"/>
+    <p:sldId id="262" r:id="rId8"/>
   </p:sldIdLst>
   <p:sldSz cx="12188825" cy="6858000"/>
   <p:notesSz cx="6858000" cy="9144000"/>
@@ -3234,13 +3235,13 @@
           <a:p>
             <a:pPr algn="ctr"/>
             <a:r>
-              <a:rPr sz="1800" b="0" i="0" dirty="0">
+              <a:rPr sz="1800" b="0" i="0">
                 <a:solidFill>
                   <a:srgbClr val="504E49"/>
                 </a:solidFill>
                 <a:latin typeface="Charter"/>
               </a:rPr>
-              <a:t>An AI analyst that diligences deals at the speed of read.</a:t>
+              <a:t>The deal-flow operating system for January Capital.</a:t>
             </a:r>
           </a:p>
         </p:txBody>
@@ -3358,8 +3359,8 @@
         </p:nvSpPr>
         <p:spPr>
           <a:xfrm>
-            <a:off x="1097280" y="548640"/>
-            <a:ext cx="9144000" cy="365760"/>
+            <a:off x="1097280" y="731520"/>
+            <a:ext cx="10058400" cy="914400"/>
           </a:xfrm>
           <a:prstGeom prst="rect">
             <a:avLst/>
@@ -3372,29 +3373,64 @@
           </a:bodyPr>
           <a:lstStyle/>
           <a:p>
-            <a:pPr algn="l"/>
-            <a:r>
-              <a:rPr sz="1100" b="0" i="0">
-                <a:solidFill>
-                  <a:srgbClr val="6B6A64"/>
+            <a:pPr algn="ctr"/>
+            <a:r>
+              <a:rPr sz="3000" b="0" i="0">
+                <a:solidFill>
+                  <a:srgbClr val="141413"/>
                 </a:solidFill>
                 <a:latin typeface="Charter"/>
               </a:rPr>
-              <a:t>01  ·  PROBLEM</a:t>
-            </a:r>
-          </a:p>
-        </p:txBody>
-      </p:sp>
-      <p:sp>
-        <p:nvSpPr>
-          <p:cNvPr id="4" name="TextBox 3"/>
+              <a:t>The bottleneck isn't sourcing.</a:t>
+            </a:r>
+          </a:p>
+        </p:txBody>
+      </p:sp>
+      <p:cxnSp>
+        <p:nvCxnSpPr>
+          <p:cNvPr id="4" name="Connector 3"/>
+          <p:cNvCxnSpPr/>
+          <p:nvPr/>
+        </p:nvCxnSpPr>
+        <p:spPr>
+          <a:xfrm>
+            <a:off x="5641848" y="1828800"/>
+            <a:ext cx="914400" cy="0"/>
+          </a:xfrm>
+          <a:prstGeom prst="line">
+            <a:avLst/>
+          </a:prstGeom>
+          <a:ln w="12700">
+            <a:solidFill>
+              <a:srgbClr val="1B365D"/>
+            </a:solidFill>
+          </a:ln>
+        </p:spPr>
+        <p:style>
+          <a:lnRef idx="2">
+            <a:schemeClr val="accent1"/>
+          </a:lnRef>
+          <a:fillRef idx="0">
+            <a:schemeClr val="accent1"/>
+          </a:fillRef>
+          <a:effectRef idx="1">
+            <a:schemeClr val="accent1"/>
+          </a:effectRef>
+          <a:fontRef idx="minor">
+            <a:schemeClr val="tx1"/>
+          </a:fontRef>
+        </p:style>
+      </p:cxnSp>
+      <p:sp>
+        <p:nvSpPr>
+          <p:cNvPr id="5" name="TextBox 4"/>
           <p:cNvSpPr txBox="1"/>
           <p:nvPr/>
         </p:nvSpPr>
         <p:spPr>
           <a:xfrm>
-            <a:off x="1097280" y="1097280"/>
-            <a:ext cx="10360152" cy="1097280"/>
+            <a:off x="1979676" y="2743200"/>
+            <a:ext cx="2560320" cy="1371600"/>
           </a:xfrm>
           <a:prstGeom prst="rect">
             <a:avLst/>
@@ -3407,29 +3443,29 @@
           </a:bodyPr>
           <a:lstStyle/>
           <a:p>
-            <a:pPr algn="l"/>
-            <a:r>
-              <a:rPr sz="3400" b="0" i="0">
-                <a:solidFill>
-                  <a:srgbClr val="141413"/>
+            <a:pPr algn="ctr"/>
+            <a:r>
+              <a:rPr sz="5600" b="0" i="0">
+                <a:solidFill>
+                  <a:srgbClr val="1B365D"/>
                 </a:solidFill>
                 <a:latin typeface="Charter"/>
               </a:rPr>
-              <a:t>Diligence is where deal flow goes to die.</a:t>
-            </a:r>
-          </a:p>
-        </p:txBody>
-      </p:sp>
-      <p:sp>
-        <p:nvSpPr>
-          <p:cNvPr id="5" name="TextBox 4"/>
+              <a:t>10,000+</a:t>
+            </a:r>
+          </a:p>
+        </p:txBody>
+      </p:sp>
+      <p:sp>
+        <p:nvSpPr>
+          <p:cNvPr id="6" name="TextBox 5"/>
           <p:cNvSpPr txBox="1"/>
           <p:nvPr/>
         </p:nvSpPr>
         <p:spPr>
           <a:xfrm>
-            <a:off x="1097280" y="2743200"/>
-            <a:ext cx="10058400" cy="3200400"/>
+            <a:off x="1979676" y="4389120"/>
+            <a:ext cx="2560320" cy="548640"/>
           </a:xfrm>
           <a:prstGeom prst="rect">
             <a:avLst/>
@@ -3442,29 +3478,29 @@
           </a:bodyPr>
           <a:lstStyle/>
           <a:p>
-            <a:pPr algn="l"/>
-            <a:r>
-              <a:rPr sz="1800" b="0" i="0" dirty="0">
-                <a:solidFill>
-                  <a:srgbClr val="3D3D3A"/>
+            <a:pPr algn="ctr"/>
+            <a:r>
+              <a:rPr sz="1400" b="0" i="0">
+                <a:solidFill>
+                  <a:srgbClr val="504E49"/>
                 </a:solidFill>
                 <a:latin typeface="Charter"/>
               </a:rPr>
-              <a:t>An associate triaging a deal opens a deck, a data room, three news tabs and an Excel model. Notes scatter, claims lose their sources, and risks live in someone's head until the IC meeting. Funds screen 10,000+ deals a year — the bottleneck is not sourcing, it is the hours per deal turning a pile of documents into a memo anyone can defend.</a:t>
-            </a:r>
-          </a:p>
-        </p:txBody>
-      </p:sp>
-      <p:sp>
-        <p:nvSpPr>
-          <p:cNvPr id="6" name="TextBox 5"/>
+              <a:t>Deals screened per year</a:t>
+            </a:r>
+          </a:p>
+        </p:txBody>
+      </p:sp>
+      <p:sp>
+        <p:nvSpPr>
+          <p:cNvPr id="7" name="TextBox 6"/>
           <p:cNvSpPr txBox="1"/>
           <p:nvPr/>
         </p:nvSpPr>
         <p:spPr>
           <a:xfrm>
-            <a:off x="10515600" y="6309360"/>
-            <a:ext cx="1371600" cy="274320"/>
+            <a:off x="4814316" y="2743200"/>
+            <a:ext cx="2560320" cy="1371600"/>
           </a:xfrm>
           <a:prstGeom prst="rect">
             <a:avLst/>
@@ -3477,15 +3513,120 @@
           </a:bodyPr>
           <a:lstStyle/>
           <a:p>
-            <a:pPr algn="r"/>
-            <a:r>
-              <a:rPr sz="1100" b="0" i="0">
-                <a:solidFill>
-                  <a:srgbClr val="6B6A64"/>
+            <a:pPr algn="ctr"/>
+            <a:r>
+              <a:rPr sz="5600" b="0" i="0">
+                <a:solidFill>
+                  <a:srgbClr val="1B365D"/>
                 </a:solidFill>
                 <a:latin typeface="Charter"/>
               </a:rPr>
-              <a:t> - 02</a:t>
+              <a:t>25</a:t>
+            </a:r>
+          </a:p>
+        </p:txBody>
+      </p:sp>
+      <p:sp>
+        <p:nvSpPr>
+          <p:cNvPr id="8" name="TextBox 7"/>
+          <p:cNvSpPr txBox="1"/>
+          <p:nvPr/>
+        </p:nvSpPr>
+        <p:spPr>
+          <a:xfrm>
+            <a:off x="4814316" y="4389120"/>
+            <a:ext cx="2560320" cy="548640"/>
+          </a:xfrm>
+          <a:prstGeom prst="rect">
+            <a:avLst/>
+          </a:prstGeom>
+          <a:noFill/>
+        </p:spPr>
+        <p:txBody>
+          <a:bodyPr wrap="square" lIns="0" tIns="0" rIns="0" bIns="0" anchor="t">
+            <a:spAutoFit/>
+          </a:bodyPr>
+          <a:lstStyle/>
+          <a:p>
+            <a:pPr algn="ctr"/>
+            <a:r>
+              <a:rPr sz="1400" b="0" i="0">
+                <a:solidFill>
+                  <a:srgbClr val="504E49"/>
+                </a:solidFill>
+                <a:latin typeface="Charter"/>
+              </a:rPr>
+              <a:t>Full-time staff</a:t>
+            </a:r>
+          </a:p>
+        </p:txBody>
+      </p:sp>
+      <p:sp>
+        <p:nvSpPr>
+          <p:cNvPr id="9" name="TextBox 8"/>
+          <p:cNvSpPr txBox="1"/>
+          <p:nvPr/>
+        </p:nvSpPr>
+        <p:spPr>
+          <a:xfrm>
+            <a:off x="7648956" y="2743200"/>
+            <a:ext cx="2560320" cy="1371600"/>
+          </a:xfrm>
+          <a:prstGeom prst="rect">
+            <a:avLst/>
+          </a:prstGeom>
+          <a:noFill/>
+        </p:spPr>
+        <p:txBody>
+          <a:bodyPr wrap="square" lIns="0" tIns="0" rIns="0" bIns="0" anchor="t">
+            <a:spAutoFit/>
+          </a:bodyPr>
+          <a:lstStyle/>
+          <a:p>
+            <a:pPr algn="ctr"/>
+            <a:r>
+              <a:rPr sz="5600" b="0" i="0">
+                <a:solidFill>
+                  <a:srgbClr val="1B365D"/>
+                </a:solidFill>
+                <a:latin typeface="Charter"/>
+              </a:rPr>
+              <a:t>60+</a:t>
+            </a:r>
+          </a:p>
+        </p:txBody>
+      </p:sp>
+      <p:sp>
+        <p:nvSpPr>
+          <p:cNvPr id="10" name="TextBox 9"/>
+          <p:cNvSpPr txBox="1"/>
+          <p:nvPr/>
+        </p:nvSpPr>
+        <p:spPr>
+          <a:xfrm>
+            <a:off x="7648956" y="4389120"/>
+            <a:ext cx="2560320" cy="548640"/>
+          </a:xfrm>
+          <a:prstGeom prst="rect">
+            <a:avLst/>
+          </a:prstGeom>
+          <a:noFill/>
+        </p:spPr>
+        <p:txBody>
+          <a:bodyPr wrap="square" lIns="0" tIns="0" rIns="0" bIns="0" anchor="t">
+            <a:spAutoFit/>
+          </a:bodyPr>
+          <a:lstStyle/>
+          <a:p>
+            <a:pPr algn="ctr"/>
+            <a:r>
+              <a:rPr sz="1400" b="0" i="0">
+                <a:solidFill>
+                  <a:srgbClr val="504E49"/>
+                </a:solidFill>
+                <a:latin typeface="Charter"/>
+              </a:rPr>
+              <a:t>Portfolio companies</a:t>
             </a:r>
           </a:p>
         </p:txBody>
@@ -3523,7 +3664,7 @@
         </p:nvSpPr>
         <p:spPr>
           <a:xfrm>
-            <a:off x="0" y="0"/>
+            <a:off x="0" y="203200"/>
             <a:ext cx="12188952" cy="6858000"/>
           </a:xfrm>
           <a:prstGeom prst="rect">
@@ -3604,7 +3745,7 @@
         <p:spPr>
           <a:xfrm>
             <a:off x="1097280" y="1005840"/>
-            <a:ext cx="10058400" cy="822960"/>
+            <a:ext cx="10058400" cy="430887"/>
           </a:xfrm>
           <a:prstGeom prst="rect">
             <a:avLst/>
@@ -3619,14 +3760,20 @@
           <a:p>
             <a:pPr algn="l"/>
             <a:r>
-              <a:rPr sz="3200" b="0" i="0">
+              <a:rPr lang="en-AU" sz="2800" b="0" i="0" dirty="0">
                 <a:solidFill>
                   <a:srgbClr val="141413"/>
                 </a:solidFill>
                 <a:latin typeface="Charter"/>
               </a:rPr>
-              <a:t>Drop in a deck. Get a cited memo. Four steps, minutes not days.</a:t>
-            </a:r>
+              <a:t>Application, Insight, Memo</a:t>
+            </a:r>
+            <a:endParaRPr sz="2800" b="0" i="0" dirty="0">
+              <a:solidFill>
+                <a:srgbClr val="141413"/>
+              </a:solidFill>
+              <a:latin typeface="Charter"/>
+            </a:endParaRPr>
           </a:p>
         </p:txBody>
       </p:sp>
@@ -3667,14 +3814,14 @@
       </p:cxnSp>
       <p:sp>
         <p:nvSpPr>
-          <p:cNvPr id="6" name="TextBox 5"/>
+          <p:cNvPr id="8" name="TextBox 7"/>
           <p:cNvSpPr txBox="1"/>
           <p:nvPr/>
         </p:nvSpPr>
         <p:spPr>
           <a:xfrm>
-            <a:off x="914400" y="2286000"/>
-            <a:ext cx="2628900" cy="731520"/>
+            <a:off x="1097280" y="5852160"/>
+            <a:ext cx="10058400" cy="365760"/>
           </a:xfrm>
           <a:prstGeom prst="rect">
             <a:avLst/>
@@ -3687,29 +3834,29 @@
           </a:bodyPr>
           <a:lstStyle/>
           <a:p>
-            <a:pPr algn="l"/>
-            <a:r>
-              <a:rPr sz="4200" b="0" i="0">
-                <a:solidFill>
-                  <a:srgbClr val="1B365D"/>
+            <a:pPr algn="ctr"/>
+            <a:r>
+              <a:rPr sz="1400" b="0" i="0">
+                <a:solidFill>
+                  <a:srgbClr val="504E49"/>
                 </a:solidFill>
                 <a:latin typeface="Charter"/>
               </a:rPr>
-              <a:t>01</a:t>
-            </a:r>
-          </a:p>
-        </p:txBody>
-      </p:sp>
-      <p:sp>
-        <p:nvSpPr>
-          <p:cNvPr id="7" name="TextBox 6"/>
+              <a:t>A URL, a founder invite, or a watch target — all converge on the same scored state.</a:t>
+            </a:r>
+          </a:p>
+        </p:txBody>
+      </p:sp>
+      <p:sp>
+        <p:nvSpPr>
+          <p:cNvPr id="9" name="TextBox 8"/>
           <p:cNvSpPr txBox="1"/>
           <p:nvPr/>
         </p:nvSpPr>
         <p:spPr>
           <a:xfrm>
-            <a:off x="914400" y="3154680"/>
-            <a:ext cx="2446020" cy="548640"/>
+            <a:off x="10515600" y="6309360"/>
+            <a:ext cx="1371600" cy="274320"/>
           </a:xfrm>
           <a:prstGeom prst="rect">
             <a:avLst/>
@@ -3722,391 +3869,6 @@
           </a:bodyPr>
           <a:lstStyle/>
           <a:p>
-            <a:pPr algn="l"/>
-            <a:r>
-              <a:rPr sz="1900" b="0" i="0">
-                <a:solidFill>
-                  <a:srgbClr val="141413"/>
-                </a:solidFill>
-                <a:latin typeface="Charter"/>
-              </a:rPr>
-              <a:t>Ingest</a:t>
-            </a:r>
-          </a:p>
-        </p:txBody>
-      </p:sp>
-      <p:sp>
-        <p:nvSpPr>
-          <p:cNvPr id="8" name="TextBox 7"/>
-          <p:cNvSpPr txBox="1"/>
-          <p:nvPr/>
-        </p:nvSpPr>
-        <p:spPr>
-          <a:xfrm>
-            <a:off x="914400" y="3794760"/>
-            <a:ext cx="2446020" cy="2011680"/>
-          </a:xfrm>
-          <a:prstGeom prst="rect">
-            <a:avLst/>
-          </a:prstGeom>
-          <a:noFill/>
-        </p:spPr>
-        <p:txBody>
-          <a:bodyPr wrap="square" lIns="0" tIns="0" rIns="0" bIns="0" anchor="t">
-            <a:spAutoFit/>
-          </a:bodyPr>
-          <a:lstStyle/>
-          <a:p>
-            <a:pPr algn="l"/>
-            <a:r>
-              <a:rPr sz="1500" b="0" i="0">
-                <a:solidFill>
-                  <a:srgbClr val="504E49"/>
-                </a:solidFill>
-                <a:latin typeface="Charter"/>
-              </a:rPr>
-              <a:t>PDFs, data-room URLs, founder notes, or chat prompts. Parsed, hashed, deduped.</a:t>
-            </a:r>
-          </a:p>
-        </p:txBody>
-      </p:sp>
-      <p:sp>
-        <p:nvSpPr>
-          <p:cNvPr id="9" name="TextBox 8"/>
-          <p:cNvSpPr txBox="1"/>
-          <p:nvPr/>
-        </p:nvSpPr>
-        <p:spPr>
-          <a:xfrm>
-            <a:off x="3543300" y="2286000"/>
-            <a:ext cx="2628900" cy="731520"/>
-          </a:xfrm>
-          <a:prstGeom prst="rect">
-            <a:avLst/>
-          </a:prstGeom>
-          <a:noFill/>
-        </p:spPr>
-        <p:txBody>
-          <a:bodyPr wrap="square" lIns="0" tIns="0" rIns="0" bIns="0" anchor="t">
-            <a:spAutoFit/>
-          </a:bodyPr>
-          <a:lstStyle/>
-          <a:p>
-            <a:pPr algn="l"/>
-            <a:r>
-              <a:rPr sz="4200" b="0" i="0">
-                <a:solidFill>
-                  <a:srgbClr val="1B365D"/>
-                </a:solidFill>
-                <a:latin typeface="Charter"/>
-              </a:rPr>
-              <a:t>02</a:t>
-            </a:r>
-          </a:p>
-        </p:txBody>
-      </p:sp>
-      <p:sp>
-        <p:nvSpPr>
-          <p:cNvPr id="10" name="TextBox 9"/>
-          <p:cNvSpPr txBox="1"/>
-          <p:nvPr/>
-        </p:nvSpPr>
-        <p:spPr>
-          <a:xfrm>
-            <a:off x="3543300" y="3154680"/>
-            <a:ext cx="2446020" cy="548640"/>
-          </a:xfrm>
-          <a:prstGeom prst="rect">
-            <a:avLst/>
-          </a:prstGeom>
-          <a:noFill/>
-        </p:spPr>
-        <p:txBody>
-          <a:bodyPr wrap="square" lIns="0" tIns="0" rIns="0" bIns="0" anchor="t">
-            <a:spAutoFit/>
-          </a:bodyPr>
-          <a:lstStyle/>
-          <a:p>
-            <a:pPr algn="l"/>
-            <a:r>
-              <a:rPr sz="1900" b="0" i="0">
-                <a:solidFill>
-                  <a:srgbClr val="141413"/>
-                </a:solidFill>
-                <a:latin typeface="Charter"/>
-              </a:rPr>
-              <a:t>Extract</a:t>
-            </a:r>
-          </a:p>
-        </p:txBody>
-      </p:sp>
-      <p:sp>
-        <p:nvSpPr>
-          <p:cNvPr id="11" name="TextBox 10"/>
-          <p:cNvSpPr txBox="1"/>
-          <p:nvPr/>
-        </p:nvSpPr>
-        <p:spPr>
-          <a:xfrm>
-            <a:off x="3543300" y="3794760"/>
-            <a:ext cx="2446020" cy="2011680"/>
-          </a:xfrm>
-          <a:prstGeom prst="rect">
-            <a:avLst/>
-          </a:prstGeom>
-          <a:noFill/>
-        </p:spPr>
-        <p:txBody>
-          <a:bodyPr wrap="square" lIns="0" tIns="0" rIns="0" bIns="0" anchor="t">
-            <a:spAutoFit/>
-          </a:bodyPr>
-          <a:lstStyle/>
-          <a:p>
-            <a:pPr algn="l"/>
-            <a:r>
-              <a:rPr sz="1500" b="0" i="0">
-                <a:solidFill>
-                  <a:srgbClr val="504E49"/>
-                </a:solidFill>
-                <a:latin typeface="Charter"/>
-              </a:rPr>
-              <a:t>GPT pulls excerpts, metrics, and claims — each insight pinned to its source line.</a:t>
-            </a:r>
-          </a:p>
-        </p:txBody>
-      </p:sp>
-      <p:sp>
-        <p:nvSpPr>
-          <p:cNvPr id="12" name="TextBox 11"/>
-          <p:cNvSpPr txBox="1"/>
-          <p:nvPr/>
-        </p:nvSpPr>
-        <p:spPr>
-          <a:xfrm>
-            <a:off x="6172200" y="2286000"/>
-            <a:ext cx="2628900" cy="731520"/>
-          </a:xfrm>
-          <a:prstGeom prst="rect">
-            <a:avLst/>
-          </a:prstGeom>
-          <a:noFill/>
-        </p:spPr>
-        <p:txBody>
-          <a:bodyPr wrap="square" lIns="0" tIns="0" rIns="0" bIns="0" anchor="t">
-            <a:spAutoFit/>
-          </a:bodyPr>
-          <a:lstStyle/>
-          <a:p>
-            <a:pPr algn="l"/>
-            <a:r>
-              <a:rPr sz="4200" b="0" i="0">
-                <a:solidFill>
-                  <a:srgbClr val="1B365D"/>
-                </a:solidFill>
-                <a:latin typeface="Charter"/>
-              </a:rPr>
-              <a:t>03</a:t>
-            </a:r>
-          </a:p>
-        </p:txBody>
-      </p:sp>
-      <p:sp>
-        <p:nvSpPr>
-          <p:cNvPr id="13" name="TextBox 12"/>
-          <p:cNvSpPr txBox="1"/>
-          <p:nvPr/>
-        </p:nvSpPr>
-        <p:spPr>
-          <a:xfrm>
-            <a:off x="6172200" y="3154680"/>
-            <a:ext cx="2446020" cy="548640"/>
-          </a:xfrm>
-          <a:prstGeom prst="rect">
-            <a:avLst/>
-          </a:prstGeom>
-          <a:noFill/>
-        </p:spPr>
-        <p:txBody>
-          <a:bodyPr wrap="square" lIns="0" tIns="0" rIns="0" bIns="0" anchor="t">
-            <a:spAutoFit/>
-          </a:bodyPr>
-          <a:lstStyle/>
-          <a:p>
-            <a:pPr algn="l"/>
-            <a:r>
-              <a:rPr sz="1900" b="0" i="0">
-                <a:solidFill>
-                  <a:srgbClr val="141413"/>
-                </a:solidFill>
-                <a:latin typeface="Charter"/>
-              </a:rPr>
-              <a:t>Score</a:t>
-            </a:r>
-          </a:p>
-        </p:txBody>
-      </p:sp>
-      <p:sp>
-        <p:nvSpPr>
-          <p:cNvPr id="14" name="TextBox 13"/>
-          <p:cNvSpPr txBox="1"/>
-          <p:nvPr/>
-        </p:nvSpPr>
-        <p:spPr>
-          <a:xfrm>
-            <a:off x="6172200" y="3794760"/>
-            <a:ext cx="2446020" cy="2011680"/>
-          </a:xfrm>
-          <a:prstGeom prst="rect">
-            <a:avLst/>
-          </a:prstGeom>
-          <a:noFill/>
-        </p:spPr>
-        <p:txBody>
-          <a:bodyPr wrap="square" lIns="0" tIns="0" rIns="0" bIns="0" anchor="t">
-            <a:spAutoFit/>
-          </a:bodyPr>
-          <a:lstStyle/>
-          <a:p>
-            <a:pPr algn="l"/>
-            <a:r>
-              <a:rPr sz="1500" b="0" i="0">
-                <a:solidFill>
-                  <a:srgbClr val="504E49"/>
-                </a:solidFill>
-                <a:latin typeface="Charter"/>
-              </a:rPr>
-              <a:t>A library of diligence checks runs every cycle. Verdict: pass, concern, or fail.</a:t>
-            </a:r>
-          </a:p>
-        </p:txBody>
-      </p:sp>
-      <p:sp>
-        <p:nvSpPr>
-          <p:cNvPr id="15" name="TextBox 14"/>
-          <p:cNvSpPr txBox="1"/>
-          <p:nvPr/>
-        </p:nvSpPr>
-        <p:spPr>
-          <a:xfrm>
-            <a:off x="8801100" y="2286000"/>
-            <a:ext cx="2628900" cy="731520"/>
-          </a:xfrm>
-          <a:prstGeom prst="rect">
-            <a:avLst/>
-          </a:prstGeom>
-          <a:noFill/>
-        </p:spPr>
-        <p:txBody>
-          <a:bodyPr wrap="square" lIns="0" tIns="0" rIns="0" bIns="0" anchor="t">
-            <a:spAutoFit/>
-          </a:bodyPr>
-          <a:lstStyle/>
-          <a:p>
-            <a:pPr algn="l"/>
-            <a:r>
-              <a:rPr sz="4200" b="0" i="0">
-                <a:solidFill>
-                  <a:srgbClr val="1B365D"/>
-                </a:solidFill>
-                <a:latin typeface="Charter"/>
-              </a:rPr>
-              <a:t>04</a:t>
-            </a:r>
-          </a:p>
-        </p:txBody>
-      </p:sp>
-      <p:sp>
-        <p:nvSpPr>
-          <p:cNvPr id="16" name="TextBox 15"/>
-          <p:cNvSpPr txBox="1"/>
-          <p:nvPr/>
-        </p:nvSpPr>
-        <p:spPr>
-          <a:xfrm>
-            <a:off x="8801100" y="3154680"/>
-            <a:ext cx="2446020" cy="548640"/>
-          </a:xfrm>
-          <a:prstGeom prst="rect">
-            <a:avLst/>
-          </a:prstGeom>
-          <a:noFill/>
-        </p:spPr>
-        <p:txBody>
-          <a:bodyPr wrap="square" lIns="0" tIns="0" rIns="0" bIns="0" anchor="t">
-            <a:spAutoFit/>
-          </a:bodyPr>
-          <a:lstStyle/>
-          <a:p>
-            <a:pPr algn="l"/>
-            <a:r>
-              <a:rPr sz="1900" b="0" i="0">
-                <a:solidFill>
-                  <a:srgbClr val="141413"/>
-                </a:solidFill>
-                <a:latin typeface="Charter"/>
-              </a:rPr>
-              <a:t>Memo</a:t>
-            </a:r>
-          </a:p>
-        </p:txBody>
-      </p:sp>
-      <p:sp>
-        <p:nvSpPr>
-          <p:cNvPr id="17" name="TextBox 16"/>
-          <p:cNvSpPr txBox="1"/>
-          <p:nvPr/>
-        </p:nvSpPr>
-        <p:spPr>
-          <a:xfrm>
-            <a:off x="8801100" y="3794760"/>
-            <a:ext cx="2446020" cy="2011680"/>
-          </a:xfrm>
-          <a:prstGeom prst="rect">
-            <a:avLst/>
-          </a:prstGeom>
-          <a:noFill/>
-        </p:spPr>
-        <p:txBody>
-          <a:bodyPr wrap="square" lIns="0" tIns="0" rIns="0" bIns="0" anchor="t">
-            <a:spAutoFit/>
-          </a:bodyPr>
-          <a:lstStyle/>
-          <a:p>
-            <a:pPr algn="l"/>
-            <a:r>
-              <a:rPr sz="1500" b="0" i="0">
-                <a:solidFill>
-                  <a:srgbClr val="504E49"/>
-                </a:solidFill>
-                <a:latin typeface="Charter"/>
-              </a:rPr>
-              <a:t>Thesis, upside, risks, recommendation — rendered live from the scored state.</a:t>
-            </a:r>
-          </a:p>
-        </p:txBody>
-      </p:sp>
-      <p:sp>
-        <p:nvSpPr>
-          <p:cNvPr id="18" name="TextBox 17"/>
-          <p:cNvSpPr txBox="1"/>
-          <p:nvPr/>
-        </p:nvSpPr>
-        <p:spPr>
-          <a:xfrm>
-            <a:off x="10515600" y="6309360"/>
-            <a:ext cx="1371600" cy="274320"/>
-          </a:xfrm>
-          <a:prstGeom prst="rect">
-            <a:avLst/>
-          </a:prstGeom>
-          <a:noFill/>
-        </p:spPr>
-        <p:txBody>
-          <a:bodyPr wrap="square" lIns="0" tIns="0" rIns="0" bIns="0" anchor="t">
-            <a:spAutoFit/>
-          </a:bodyPr>
-          <a:lstStyle/>
-          <a:p>
             <a:pPr algn="r"/>
             <a:r>
               <a:rPr sz="1100" b="0" i="0">
@@ -4120,6 +3882,96 @@
           </a:p>
         </p:txBody>
       </p:sp>
+      <p:pic>
+        <p:nvPicPr>
+          <p:cNvPr id="10" name="Picture 9">
+            <a:extLst>
+              <a:ext uri="{FF2B5EF4-FFF2-40B4-BE49-F238E27FC236}">
+                <a16:creationId xmlns:a16="http://schemas.microsoft.com/office/drawing/2014/main" id="{1444423D-D0BE-3F59-9DA8-90FDA070EB16}"/>
+              </a:ext>
+            </a:extLst>
+          </p:cNvPr>
+          <p:cNvPicPr>
+            <a:picLocks noChangeAspect="1"/>
+          </p:cNvPicPr>
+          <p:nvPr/>
+        </p:nvPicPr>
+        <p:blipFill>
+          <a:blip r:embed="rId2"/>
+          <a:stretch>
+            <a:fillRect/>
+          </a:stretch>
+        </p:blipFill>
+        <p:spPr>
+          <a:xfrm>
+            <a:off x="8460668" y="2274090"/>
+            <a:ext cx="2112916" cy="2759283"/>
+          </a:xfrm>
+          <a:prstGeom prst="rect">
+            <a:avLst/>
+          </a:prstGeom>
+        </p:spPr>
+      </p:pic>
+      <p:pic>
+        <p:nvPicPr>
+          <p:cNvPr id="15" name="Picture 14">
+            <a:extLst>
+              <a:ext uri="{FF2B5EF4-FFF2-40B4-BE49-F238E27FC236}">
+                <a16:creationId xmlns:a16="http://schemas.microsoft.com/office/drawing/2014/main" id="{52BA9BF3-788E-CFF0-CEE8-FBDEBB985C7C}"/>
+              </a:ext>
+            </a:extLst>
+          </p:cNvPr>
+          <p:cNvPicPr>
+            <a:picLocks noChangeAspect="1"/>
+          </p:cNvPicPr>
+          <p:nvPr/>
+        </p:nvPicPr>
+        <p:blipFill>
+          <a:blip r:embed="rId3"/>
+          <a:stretch>
+            <a:fillRect/>
+          </a:stretch>
+        </p:blipFill>
+        <p:spPr>
+          <a:xfrm>
+            <a:off x="1097280" y="2237608"/>
+            <a:ext cx="2284303" cy="2792241"/>
+          </a:xfrm>
+          <a:prstGeom prst="rect">
+            <a:avLst/>
+          </a:prstGeom>
+        </p:spPr>
+      </p:pic>
+      <p:pic>
+        <p:nvPicPr>
+          <p:cNvPr id="17" name="Picture 16">
+            <a:extLst>
+              <a:ext uri="{FF2B5EF4-FFF2-40B4-BE49-F238E27FC236}">
+                <a16:creationId xmlns:a16="http://schemas.microsoft.com/office/drawing/2014/main" id="{4C3747EE-DECA-B070-0B4D-EB7810EC26A7}"/>
+              </a:ext>
+            </a:extLst>
+          </p:cNvPr>
+          <p:cNvPicPr>
+            <a:picLocks noChangeAspect="1"/>
+          </p:cNvPicPr>
+          <p:nvPr/>
+        </p:nvPicPr>
+        <p:blipFill>
+          <a:blip r:embed="rId4"/>
+          <a:stretch>
+            <a:fillRect/>
+          </a:stretch>
+        </p:blipFill>
+        <p:spPr>
+          <a:xfrm>
+            <a:off x="3561219" y="2249586"/>
+            <a:ext cx="4671803" cy="2759283"/>
+          </a:xfrm>
+          <a:prstGeom prst="rect">
+            <a:avLst/>
+          </a:prstGeom>
+        </p:spPr>
+      </p:pic>
     </p:spTree>
   </p:cSld>
   <p:clrMapOvr>
@@ -4220,28 +4072,63 @@
                 </a:solidFill>
                 <a:latin typeface="Charter"/>
               </a:rPr>
-              <a:t>03  ·  TECHNICAL DEPTH</a:t>
+              <a:t>03  ·  WATCH THIS</a:t>
+            </a:r>
+          </a:p>
+        </p:txBody>
+      </p:sp>
+      <p:sp>
+        <p:nvSpPr>
+          <p:cNvPr id="4" name="TextBox 3"/>
+          <p:cNvSpPr txBox="1"/>
+          <p:nvPr/>
+        </p:nvSpPr>
+        <p:spPr>
+          <a:xfrm>
+            <a:off x="1097280" y="1005840"/>
+            <a:ext cx="10058400" cy="822960"/>
+          </a:xfrm>
+          <a:prstGeom prst="rect">
+            <a:avLst/>
+          </a:prstGeom>
+          <a:noFill/>
+        </p:spPr>
+        <p:txBody>
+          <a:bodyPr wrap="square" lIns="0" tIns="0" rIns="0" bIns="0" anchor="t">
+            <a:spAutoFit/>
+          </a:bodyPr>
+          <a:lstStyle/>
+          <a:p>
+            <a:pPr algn="l"/>
+            <a:r>
+              <a:rPr sz="3200" b="0" i="0">
+                <a:solidFill>
+                  <a:srgbClr val="141413"/>
+                </a:solidFill>
+                <a:latin typeface="Charter"/>
+              </a:rPr>
+              <a:t>One loop. Four steps. Live, on a real deal.</a:t>
             </a:r>
           </a:p>
         </p:txBody>
       </p:sp>
       <p:cxnSp>
         <p:nvCxnSpPr>
-          <p:cNvPr id="4" name="Connector 3"/>
+          <p:cNvPr id="5" name="Connector 4"/>
           <p:cNvCxnSpPr/>
           <p:nvPr/>
         </p:nvCxnSpPr>
         <p:spPr>
           <a:xfrm>
-            <a:off x="6099048" y="914400"/>
-            <a:ext cx="0" cy="5303520"/>
+            <a:off x="1097280" y="1965960"/>
+            <a:ext cx="10058400" cy="0"/>
           </a:xfrm>
           <a:prstGeom prst="line">
             <a:avLst/>
           </a:prstGeom>
-          <a:ln w="12700">
+          <a:ln w="6350">
             <a:solidFill>
-              <a:srgbClr val="E8E6DC"/>
+              <a:srgbClr val="1B365D"/>
             </a:solidFill>
           </a:ln>
         </p:spPr>
@@ -4262,14 +4149,14 @@
       </p:cxnSp>
       <p:sp>
         <p:nvSpPr>
-          <p:cNvPr id="5" name="TextBox 4"/>
+          <p:cNvPr id="6" name="TextBox 5"/>
           <p:cNvSpPr txBox="1"/>
           <p:nvPr/>
         </p:nvSpPr>
         <p:spPr>
           <a:xfrm>
-            <a:off x="1097280" y="1097280"/>
-            <a:ext cx="4572000" cy="731520"/>
+            <a:off x="914400" y="2286000"/>
+            <a:ext cx="2628900" cy="731520"/>
           </a:xfrm>
           <a:prstGeom prst="rect">
             <a:avLst/>
@@ -4284,27 +4171,27 @@
           <a:p>
             <a:pPr algn="l"/>
             <a:r>
-              <a:rPr sz="2200" b="0" i="0">
-                <a:solidFill>
-                  <a:srgbClr val="504E49"/>
+              <a:rPr sz="4200" b="0" i="0">
+                <a:solidFill>
+                  <a:srgbClr val="1B365D"/>
                 </a:solidFill>
                 <a:latin typeface="Charter"/>
               </a:rPr>
-              <a:t>Stack</a:t>
-            </a:r>
-          </a:p>
-        </p:txBody>
-      </p:sp>
-      <p:sp>
-        <p:nvSpPr>
-          <p:cNvPr id="6" name="TextBox 5"/>
+              <a:t>01</a:t>
+            </a:r>
+          </a:p>
+        </p:txBody>
+      </p:sp>
+      <p:sp>
+        <p:nvSpPr>
+          <p:cNvPr id="7" name="TextBox 6"/>
           <p:cNvSpPr txBox="1"/>
           <p:nvPr/>
         </p:nvSpPr>
         <p:spPr>
           <a:xfrm>
-            <a:off x="6400800" y="1097280"/>
-            <a:ext cx="4572000" cy="731520"/>
+            <a:off x="914400" y="3154680"/>
+            <a:ext cx="2446020" cy="548640"/>
           </a:xfrm>
           <a:prstGeom prst="rect">
             <a:avLst/>
@@ -4319,52 +4206,17 @@
           <a:p>
             <a:pPr algn="l"/>
             <a:r>
-              <a:rPr sz="2200" b="0" i="0">
+              <a:rPr sz="1900" b="0" i="0">
                 <a:solidFill>
                   <a:srgbClr val="141413"/>
                 </a:solidFill>
                 <a:latin typeface="Charter"/>
               </a:rPr>
-              <a:t>Why it holds up</a:t>
-            </a:r>
-          </a:p>
-        </p:txBody>
-      </p:sp>
-      <p:cxnSp>
-        <p:nvCxnSpPr>
-          <p:cNvPr id="7" name="Connector 6"/>
-          <p:cNvCxnSpPr/>
-          <p:nvPr/>
-        </p:nvCxnSpPr>
-        <p:spPr>
-          <a:xfrm>
-            <a:off x="1097280" y="2011680"/>
-            <a:ext cx="10515600" cy="0"/>
-          </a:xfrm>
-          <a:prstGeom prst="line">
-            <a:avLst/>
-          </a:prstGeom>
-          <a:ln w="6350">
-            <a:solidFill>
-              <a:srgbClr val="1B365D"/>
-            </a:solidFill>
-          </a:ln>
-        </p:spPr>
-        <p:style>
-          <a:lnRef idx="2">
-            <a:schemeClr val="accent1"/>
-          </a:lnRef>
-          <a:fillRef idx="0">
-            <a:schemeClr val="accent1"/>
-          </a:fillRef>
-          <a:effectRef idx="1">
-            <a:schemeClr val="accent1"/>
-          </a:effectRef>
-          <a:fontRef idx="minor">
-            <a:schemeClr val="tx1"/>
-          </a:fontRef>
-        </p:style>
-      </p:cxnSp>
+              <a:t>Add</a:t>
+            </a:r>
+          </a:p>
+        </p:txBody>
+      </p:sp>
       <p:sp>
         <p:nvSpPr>
           <p:cNvPr id="8" name="TextBox 7"/>
@@ -4373,8 +4225,8 @@
         </p:nvSpPr>
         <p:spPr>
           <a:xfrm>
-            <a:off x="1097280" y="2377440"/>
-            <a:ext cx="4480560" cy="640080"/>
+            <a:off x="914400" y="3794760"/>
+            <a:ext cx="2446020" cy="2011680"/>
           </a:xfrm>
           <a:prstGeom prst="rect">
             <a:avLst/>
@@ -4389,13 +4241,13 @@
           <a:p>
             <a:pPr algn="l"/>
             <a:r>
-              <a:rPr sz="1700" b="0" i="0">
-                <a:solidFill>
-                  <a:srgbClr val="6B6A64"/>
+              <a:rPr sz="1500" b="0" i="0">
+                <a:solidFill>
+                  <a:srgbClr val="504E49"/>
                 </a:solidFill>
                 <a:latin typeface="Charter"/>
               </a:rPr>
-              <a:t>OpenAI Responses + web search + file ingest</a:t>
+              <a:t>URL alone, or send a token-gated /apply link. Either way, market + founder research lanes spin up automatically.</a:t>
             </a:r>
           </a:p>
         </p:txBody>
@@ -4408,8 +4260,8 @@
         </p:nvSpPr>
         <p:spPr>
           <a:xfrm>
-            <a:off x="1097280" y="3200400"/>
-            <a:ext cx="4480560" cy="640080"/>
+            <a:off x="3543300" y="2286000"/>
+            <a:ext cx="2628900" cy="731520"/>
           </a:xfrm>
           <a:prstGeom prst="rect">
             <a:avLst/>
@@ -4424,13 +4276,13 @@
           <a:p>
             <a:pPr algn="l"/>
             <a:r>
-              <a:rPr sz="1700" b="0" i="0">
-                <a:solidFill>
-                  <a:srgbClr val="6B6A64"/>
+              <a:rPr sz="4200" b="0" i="0">
+                <a:solidFill>
+                  <a:srgbClr val="1B365D"/>
                 </a:solidFill>
                 <a:latin typeface="Charter"/>
               </a:rPr>
-              <a:t>Effect-TS workflows, durable retries on every step</a:t>
+              <a:t>02</a:t>
             </a:r>
           </a:p>
         </p:txBody>
@@ -4443,8 +4295,8 @@
         </p:nvSpPr>
         <p:spPr>
           <a:xfrm>
-            <a:off x="1097280" y="4023360"/>
-            <a:ext cx="4480560" cy="640080"/>
+            <a:off x="3543300" y="3154680"/>
+            <a:ext cx="2446020" cy="548640"/>
           </a:xfrm>
           <a:prstGeom prst="rect">
             <a:avLst/>
@@ -4459,13 +4311,13 @@
           <a:p>
             <a:pPr algn="l"/>
             <a:r>
-              <a:rPr sz="1700" b="0" i="0">
-                <a:solidFill>
-                  <a:srgbClr val="6B6A64"/>
+              <a:rPr sz="1900" b="0" i="0">
+                <a:solidFill>
+                  <a:srgbClr val="141413"/>
                 </a:solidFill>
                 <a:latin typeface="Charter"/>
               </a:rPr>
-              <a:t>Postgres + Drizzle, content-hashed source store</a:t>
+              <a:t>Watch</a:t>
             </a:r>
           </a:p>
         </p:txBody>
@@ -4478,8 +4330,8 @@
         </p:nvSpPr>
         <p:spPr>
           <a:xfrm>
-            <a:off x="1097280" y="4846320"/>
-            <a:ext cx="4480560" cy="640080"/>
+            <a:off x="3543300" y="3794760"/>
+            <a:ext cx="2446020" cy="2011680"/>
           </a:xfrm>
           <a:prstGeom prst="rect">
             <a:avLst/>
@@ -4494,13 +4346,13 @@
           <a:p>
             <a:pPr algn="l"/>
             <a:r>
-              <a:rPr sz="1700" b="0" i="0">
-                <a:solidFill>
-                  <a:srgbClr val="6B6A64"/>
+              <a:rPr sz="1500" b="0" i="0">
+                <a:solidFill>
+                  <a:srgbClr val="504E49"/>
                 </a:solidFill>
                 <a:latin typeface="Charter"/>
               </a:rPr>
-              <a:t>Per-check engine versioning, deterministic re-runs</a:t>
+              <a:t>Cron scans HN Launch, ProductHunt, TechCrunch, BusinessWire — plus pinned web pages and X profiles per deal.</a:t>
             </a:r>
           </a:p>
         </p:txBody>
@@ -4513,8 +4365,8 @@
         </p:nvSpPr>
         <p:spPr>
           <a:xfrm>
-            <a:off x="6400800" y="2377440"/>
-            <a:ext cx="4754880" cy="640080"/>
+            <a:off x="6172200" y="2286000"/>
+            <a:ext cx="2628900" cy="731520"/>
           </a:xfrm>
           <a:prstGeom prst="rect">
             <a:avLst/>
@@ -4529,13 +4381,13 @@
           <a:p>
             <a:pPr algn="l"/>
             <a:r>
-              <a:rPr sz="1700" b="0" i="0">
-                <a:solidFill>
-                  <a:srgbClr val="3D3D3A"/>
+              <a:rPr sz="4200" b="0" i="0">
+                <a:solidFill>
+                  <a:srgbClr val="1B365D"/>
                 </a:solidFill>
                 <a:latin typeface="Charter"/>
               </a:rPr>
-              <a:t>Every claim cites the exact source line</a:t>
+              <a:t>03</a:t>
             </a:r>
           </a:p>
         </p:txBody>
@@ -4548,8 +4400,8 @@
         </p:nvSpPr>
         <p:spPr>
           <a:xfrm>
-            <a:off x="6400800" y="3200400"/>
-            <a:ext cx="4754880" cy="640080"/>
+            <a:off x="6172200" y="3154680"/>
+            <a:ext cx="2446020" cy="548640"/>
           </a:xfrm>
           <a:prstGeom prst="rect">
             <a:avLst/>
@@ -4564,13 +4416,13 @@
           <a:p>
             <a:pPr algn="l"/>
             <a:r>
-              <a:rPr sz="1700" b="0" i="0">
-                <a:solidFill>
-                  <a:srgbClr val="3D3D3A"/>
+              <a:rPr sz="1900" b="0" i="0">
+                <a:solidFill>
+                  <a:srgbClr val="141413"/>
                 </a:solidFill>
                 <a:latin typeface="Charter"/>
               </a:rPr>
-              <a:t>Re-running on the same inputs yields the same memo</a:t>
+              <a:t>Score</a:t>
             </a:r>
           </a:p>
         </p:txBody>
@@ -4583,8 +4435,8 @@
         </p:nvSpPr>
         <p:spPr>
           <a:xfrm>
-            <a:off x="6400800" y="4023360"/>
-            <a:ext cx="4754880" cy="640080"/>
+            <a:off x="6172200" y="3794760"/>
+            <a:ext cx="2446020" cy="2011680"/>
           </a:xfrm>
           <a:prstGeom prst="rect">
             <a:avLst/>
@@ -4599,13 +4451,13 @@
           <a:p>
             <a:pPr algn="l"/>
             <a:r>
-              <a:rPr sz="1700" b="0" i="0">
-                <a:solidFill>
-                  <a:srgbClr val="3D3D3A"/>
+              <a:rPr sz="1500" b="0" i="0">
+                <a:solidFill>
+                  <a:srgbClr val="504E49"/>
                 </a:solidFill>
                 <a:latin typeface="Charter"/>
               </a:rPr>
-              <a:t>Overrides and rationales survive engine upgrades</a:t>
+              <a:t>Your diligence library runs on every signal. Pass / concern / fail, each cited to source.</a:t>
             </a:r>
           </a:p>
         </p:txBody>
@@ -4618,8 +4470,8 @@
         </p:nvSpPr>
         <p:spPr>
           <a:xfrm>
-            <a:off x="6400800" y="4846320"/>
-            <a:ext cx="4754880" cy="640080"/>
+            <a:off x="8801100" y="2286000"/>
+            <a:ext cx="2628900" cy="731520"/>
           </a:xfrm>
           <a:prstGeom prst="rect">
             <a:avLst/>
@@ -4634,13 +4486,13 @@
           <a:p>
             <a:pPr algn="l"/>
             <a:r>
-              <a:rPr sz="1700" b="0" i="0">
-                <a:solidFill>
-                  <a:srgbClr val="3D3D3A"/>
+              <a:rPr sz="4200" b="0" i="0">
+                <a:solidFill>
+                  <a:srgbClr val="1B365D"/>
                 </a:solidFill>
                 <a:latin typeface="Charter"/>
               </a:rPr>
-              <a:t>Adding a check is a definition file, not a model retrain</a:t>
+              <a:t>04</a:t>
             </a:r>
           </a:p>
         </p:txBody>
@@ -4648,6 +4500,76 @@
       <p:sp>
         <p:nvSpPr>
           <p:cNvPr id="16" name="TextBox 15"/>
+          <p:cNvSpPr txBox="1"/>
+          <p:nvPr/>
+        </p:nvSpPr>
+        <p:spPr>
+          <a:xfrm>
+            <a:off x="8801100" y="3154680"/>
+            <a:ext cx="2446020" cy="548640"/>
+          </a:xfrm>
+          <a:prstGeom prst="rect">
+            <a:avLst/>
+          </a:prstGeom>
+          <a:noFill/>
+        </p:spPr>
+        <p:txBody>
+          <a:bodyPr wrap="square" lIns="0" tIns="0" rIns="0" bIns="0" anchor="t">
+            <a:spAutoFit/>
+          </a:bodyPr>
+          <a:lstStyle/>
+          <a:p>
+            <a:pPr algn="l"/>
+            <a:r>
+              <a:rPr sz="1900" b="0" i="0">
+                <a:solidFill>
+                  <a:srgbClr val="141413"/>
+                </a:solidFill>
+                <a:latin typeface="Charter"/>
+              </a:rPr>
+              <a:t>Memo</a:t>
+            </a:r>
+          </a:p>
+        </p:txBody>
+      </p:sp>
+      <p:sp>
+        <p:nvSpPr>
+          <p:cNvPr id="17" name="TextBox 16"/>
+          <p:cNvSpPr txBox="1"/>
+          <p:nvPr/>
+        </p:nvSpPr>
+        <p:spPr>
+          <a:xfrm>
+            <a:off x="8801100" y="3794760"/>
+            <a:ext cx="2446020" cy="2011680"/>
+          </a:xfrm>
+          <a:prstGeom prst="rect">
+            <a:avLst/>
+          </a:prstGeom>
+          <a:noFill/>
+        </p:spPr>
+        <p:txBody>
+          <a:bodyPr wrap="square" lIns="0" tIns="0" rIns="0" bIns="0" anchor="t">
+            <a:spAutoFit/>
+          </a:bodyPr>
+          <a:lstStyle/>
+          <a:p>
+            <a:pPr algn="l"/>
+            <a:r>
+              <a:rPr sz="1500" b="0" i="0">
+                <a:solidFill>
+                  <a:srgbClr val="504E49"/>
+                </a:solidFill>
+                <a:latin typeface="Charter"/>
+              </a:rPr>
+              <a:t>Narrative + executive summary, 1-3 pages, versioned. Re-renders the moment state changes.</a:t>
+            </a:r>
+          </a:p>
+        </p:txBody>
+      </p:sp>
+      <p:sp>
+        <p:nvSpPr>
+          <p:cNvPr id="18" name="TextBox 17"/>
           <p:cNvSpPr txBox="1"/>
           <p:nvPr/>
         </p:nvSpPr>
@@ -4758,8 +4680,8 @@
         </p:nvSpPr>
         <p:spPr>
           <a:xfrm>
-            <a:off x="1097280" y="731520"/>
-            <a:ext cx="10058400" cy="914400"/>
+            <a:off x="1097280" y="548640"/>
+            <a:ext cx="9144000" cy="365760"/>
           </a:xfrm>
           <a:prstGeom prst="rect">
             <a:avLst/>
@@ -4772,15 +4694,15 @@
           </a:bodyPr>
           <a:lstStyle/>
           <a:p>
-            <a:pPr algn="ctr"/>
-            <a:r>
-              <a:rPr sz="3000" b="0" i="0">
-                <a:solidFill>
-                  <a:srgbClr val="141413"/>
+            <a:pPr algn="l"/>
+            <a:r>
+              <a:rPr sz="1100" b="0" i="0">
+                <a:solidFill>
+                  <a:srgbClr val="6B6A64"/>
                 </a:solidFill>
                 <a:latin typeface="Charter"/>
               </a:rPr>
-              <a:t>Built for funds that screen thousands of deals a year.</a:t>
+              <a:t>04  ·  TECHNICAL DEPTH</a:t>
             </a:r>
           </a:p>
         </p:txBody>
@@ -4793,15 +4715,15 @@
         </p:nvCxnSpPr>
         <p:spPr>
           <a:xfrm>
-            <a:off x="5641848" y="1828800"/>
-            <a:ext cx="914400" cy="0"/>
+            <a:off x="6099048" y="914400"/>
+            <a:ext cx="0" cy="5303520"/>
           </a:xfrm>
           <a:prstGeom prst="line">
             <a:avLst/>
           </a:prstGeom>
           <a:ln w="12700">
             <a:solidFill>
-              <a:srgbClr val="1B365D"/>
+              <a:srgbClr val="E8E6DC"/>
             </a:solidFill>
           </a:ln>
         </p:spPr>
@@ -4828,8 +4750,8 @@
         </p:nvSpPr>
         <p:spPr>
           <a:xfrm>
-            <a:off x="562356" y="2743200"/>
-            <a:ext cx="2560320" cy="1371600"/>
+            <a:off x="1097280" y="1097280"/>
+            <a:ext cx="4572000" cy="731520"/>
           </a:xfrm>
           <a:prstGeom prst="rect">
             <a:avLst/>
@@ -4842,15 +4764,15 @@
           </a:bodyPr>
           <a:lstStyle/>
           <a:p>
-            <a:pPr algn="ctr"/>
-            <a:r>
-              <a:rPr sz="5600" b="0" i="0">
-                <a:solidFill>
-                  <a:srgbClr val="1B365D"/>
+            <a:pPr algn="l"/>
+            <a:r>
+              <a:rPr sz="2200" b="0" i="0">
+                <a:solidFill>
+                  <a:srgbClr val="504E49"/>
                 </a:solidFill>
                 <a:latin typeface="Charter"/>
               </a:rPr>
-              <a:t>10,000+</a:t>
+              <a:t>Stack</a:t>
             </a:r>
           </a:p>
         </p:txBody>
@@ -4863,8 +4785,8 @@
         </p:nvSpPr>
         <p:spPr>
           <a:xfrm>
-            <a:off x="562356" y="4389120"/>
-            <a:ext cx="2560320" cy="548640"/>
+            <a:off x="6400800" y="1097280"/>
+            <a:ext cx="4572000" cy="731520"/>
           </a:xfrm>
           <a:prstGeom prst="rect">
             <a:avLst/>
@@ -4877,29 +4799,64 @@
           </a:bodyPr>
           <a:lstStyle/>
           <a:p>
-            <a:pPr algn="ctr"/>
-            <a:r>
-              <a:rPr sz="1400" b="0" i="0">
-                <a:solidFill>
-                  <a:srgbClr val="504E49"/>
+            <a:pPr algn="l"/>
+            <a:r>
+              <a:rPr sz="2200" b="0" i="0">
+                <a:solidFill>
+                  <a:srgbClr val="141413"/>
                 </a:solidFill>
                 <a:latin typeface="Charter"/>
               </a:rPr>
-              <a:t>Deals screened / fund / year</a:t>
-            </a:r>
-          </a:p>
-        </p:txBody>
-      </p:sp>
-      <p:sp>
-        <p:nvSpPr>
-          <p:cNvPr id="7" name="TextBox 6"/>
+              <a:t>Why it holds up on real money</a:t>
+            </a:r>
+          </a:p>
+        </p:txBody>
+      </p:sp>
+      <p:cxnSp>
+        <p:nvCxnSpPr>
+          <p:cNvPr id="7" name="Connector 6"/>
+          <p:cNvCxnSpPr/>
+          <p:nvPr/>
+        </p:nvCxnSpPr>
+        <p:spPr>
+          <a:xfrm>
+            <a:off x="1097280" y="2011680"/>
+            <a:ext cx="10515600" cy="0"/>
+          </a:xfrm>
+          <a:prstGeom prst="line">
+            <a:avLst/>
+          </a:prstGeom>
+          <a:ln w="6350">
+            <a:solidFill>
+              <a:srgbClr val="1B365D"/>
+            </a:solidFill>
+          </a:ln>
+        </p:spPr>
+        <p:style>
+          <a:lnRef idx="2">
+            <a:schemeClr val="accent1"/>
+          </a:lnRef>
+          <a:fillRef idx="0">
+            <a:schemeClr val="accent1"/>
+          </a:fillRef>
+          <a:effectRef idx="1">
+            <a:schemeClr val="accent1"/>
+          </a:effectRef>
+          <a:fontRef idx="minor">
+            <a:schemeClr val="tx1"/>
+          </a:fontRef>
+        </p:style>
+      </p:cxnSp>
+      <p:sp>
+        <p:nvSpPr>
+          <p:cNvPr id="8" name="TextBox 7"/>
           <p:cNvSpPr txBox="1"/>
           <p:nvPr/>
         </p:nvSpPr>
         <p:spPr>
           <a:xfrm>
-            <a:off x="3396996" y="2743200"/>
-            <a:ext cx="2560320" cy="1371600"/>
+            <a:off x="1097280" y="2377440"/>
+            <a:ext cx="4480560" cy="640080"/>
           </a:xfrm>
           <a:prstGeom prst="rect">
             <a:avLst/>
@@ -4912,29 +4869,29 @@
           </a:bodyPr>
           <a:lstStyle/>
           <a:p>
-            <a:pPr algn="ctr"/>
-            <a:r>
-              <a:rPr sz="5600" b="0" i="0">
-                <a:solidFill>
-                  <a:srgbClr val="1B365D"/>
+            <a:pPr algn="l"/>
+            <a:r>
+              <a:rPr sz="1700" b="0" i="0">
+                <a:solidFill>
+                  <a:srgbClr val="6B6A64"/>
                 </a:solidFill>
                 <a:latin typeface="Charter"/>
               </a:rPr>
-              <a:t>60%</a:t>
-            </a:r>
-          </a:p>
-        </p:txBody>
-      </p:sp>
-      <p:sp>
-        <p:nvSpPr>
-          <p:cNvPr id="8" name="TextBox 7"/>
+              <a:t>Effect-TS durable execution + cron, Postgres-backed</a:t>
+            </a:r>
+          </a:p>
+        </p:txBody>
+      </p:sp>
+      <p:sp>
+        <p:nvSpPr>
+          <p:cNvPr id="9" name="TextBox 8"/>
           <p:cNvSpPr txBox="1"/>
           <p:nvPr/>
         </p:nvSpPr>
         <p:spPr>
           <a:xfrm>
-            <a:off x="3396996" y="4389120"/>
-            <a:ext cx="2560320" cy="548640"/>
+            <a:off x="1097280" y="3200400"/>
+            <a:ext cx="4480560" cy="640080"/>
           </a:xfrm>
           <a:prstGeom prst="rect">
             <a:avLst/>
@@ -4947,29 +4904,29 @@
           </a:bodyPr>
           <a:lstStyle/>
           <a:p>
-            <a:pPr algn="ctr"/>
-            <a:r>
-              <a:rPr sz="1400" b="0" i="0">
-                <a:solidFill>
-                  <a:srgbClr val="504E49"/>
+            <a:pPr algn="l"/>
+            <a:r>
+              <a:rPr sz="1700" b="0" i="0">
+                <a:solidFill>
+                  <a:srgbClr val="6B6A64"/>
                 </a:solidFill>
                 <a:latin typeface="Charter"/>
               </a:rPr>
-              <a:t>Associate time on repetitive diligence</a:t>
-            </a:r>
-          </a:p>
-        </p:txBody>
-      </p:sp>
-      <p:sp>
-        <p:nvSpPr>
-          <p:cNvPr id="9" name="TextBox 8"/>
+              <a:t>OpenAI Responses + web search + file ingest</a:t>
+            </a:r>
+          </a:p>
+        </p:txBody>
+      </p:sp>
+      <p:sp>
+        <p:nvSpPr>
+          <p:cNvPr id="11" name="TextBox 10"/>
           <p:cNvSpPr txBox="1"/>
           <p:nvPr/>
         </p:nvSpPr>
         <p:spPr>
           <a:xfrm>
-            <a:off x="6231636" y="2743200"/>
-            <a:ext cx="2560320" cy="1371600"/>
+            <a:off x="1097280" y="3840480"/>
+            <a:ext cx="4480560" cy="640080"/>
           </a:xfrm>
           <a:prstGeom prst="rect">
             <a:avLst/>
@@ -4982,29 +4939,29 @@
           </a:bodyPr>
           <a:lstStyle/>
           <a:p>
-            <a:pPr algn="ctr"/>
-            <a:r>
-              <a:rPr sz="5600" b="0" i="0">
-                <a:solidFill>
-                  <a:srgbClr val="1B365D"/>
+            <a:pPr algn="l"/>
+            <a:r>
+              <a:rPr sz="1700" b="0" i="0" dirty="0">
+                <a:solidFill>
+                  <a:srgbClr val="6B6A64"/>
                 </a:solidFill>
                 <a:latin typeface="Charter"/>
               </a:rPr>
-              <a:t>4 hrs</a:t>
-            </a:r>
-          </a:p>
-        </p:txBody>
-      </p:sp>
-      <p:sp>
-        <p:nvSpPr>
-          <p:cNvPr id="10" name="TextBox 9"/>
+              <a:t>Railway deploy, fronted by Cloudflare</a:t>
+            </a:r>
+          </a:p>
+        </p:txBody>
+      </p:sp>
+      <p:sp>
+        <p:nvSpPr>
+          <p:cNvPr id="12" name="TextBox 11"/>
           <p:cNvSpPr txBox="1"/>
           <p:nvPr/>
         </p:nvSpPr>
         <p:spPr>
           <a:xfrm>
-            <a:off x="6231636" y="4389120"/>
-            <a:ext cx="2560320" cy="548640"/>
+            <a:off x="6400800" y="2377440"/>
+            <a:ext cx="4754880" cy="640080"/>
           </a:xfrm>
           <a:prstGeom prst="rect">
             <a:avLst/>
@@ -5017,29 +4974,29 @@
           </a:bodyPr>
           <a:lstStyle/>
           <a:p>
-            <a:pPr algn="ctr"/>
-            <a:r>
-              <a:rPr sz="1400" b="0" i="0">
-                <a:solidFill>
-                  <a:srgbClr val="504E49"/>
+            <a:pPr algn="l"/>
+            <a:r>
+              <a:rPr sz="1700" b="0" i="0">
+                <a:solidFill>
+                  <a:srgbClr val="3D3D3A"/>
                 </a:solidFill>
                 <a:latin typeface="Charter"/>
               </a:rPr>
-              <a:t>Deck-to-memo on Capital</a:t>
-            </a:r>
-          </a:p>
-        </p:txBody>
-      </p:sp>
-      <p:sp>
-        <p:nvSpPr>
-          <p:cNvPr id="11" name="TextBox 10"/>
+              <a:t>Every claim cites the exact source line</a:t>
+            </a:r>
+          </a:p>
+        </p:txBody>
+      </p:sp>
+      <p:sp>
+        <p:nvSpPr>
+          <p:cNvPr id="13" name="TextBox 12"/>
           <p:cNvSpPr txBox="1"/>
           <p:nvPr/>
         </p:nvSpPr>
         <p:spPr>
           <a:xfrm>
-            <a:off x="9066276" y="2743200"/>
-            <a:ext cx="2560320" cy="1371600"/>
+            <a:off x="6400800" y="3200400"/>
+            <a:ext cx="4754880" cy="640080"/>
           </a:xfrm>
           <a:prstGeom prst="rect">
             <a:avLst/>
@@ -5052,29 +5009,29 @@
           </a:bodyPr>
           <a:lstStyle/>
           <a:p>
-            <a:pPr algn="ctr"/>
-            <a:r>
-              <a:rPr sz="5600" b="0" i="0">
-                <a:solidFill>
-                  <a:srgbClr val="1B365D"/>
+            <a:pPr algn="l"/>
+            <a:r>
+              <a:rPr sz="1700" b="0" i="0">
+                <a:solidFill>
+                  <a:srgbClr val="3D3D3A"/>
                 </a:solidFill>
                 <a:latin typeface="Charter"/>
               </a:rPr>
-              <a:t>100%</a:t>
-            </a:r>
-          </a:p>
-        </p:txBody>
-      </p:sp>
-      <p:sp>
-        <p:nvSpPr>
-          <p:cNvPr id="12" name="TextBox 11"/>
+              <a:t>Deterministic re-runs; engine-versioned checks</a:t>
+            </a:r>
+          </a:p>
+        </p:txBody>
+      </p:sp>
+      <p:sp>
+        <p:nvSpPr>
+          <p:cNvPr id="14" name="TextBox 13"/>
           <p:cNvSpPr txBox="1"/>
           <p:nvPr/>
         </p:nvSpPr>
         <p:spPr>
           <a:xfrm>
-            <a:off x="9066276" y="4389120"/>
-            <a:ext cx="2560320" cy="548640"/>
+            <a:off x="6400800" y="4023360"/>
+            <a:ext cx="4754880" cy="640080"/>
           </a:xfrm>
           <a:prstGeom prst="rect">
             <a:avLst/>
@@ -5087,15 +5044,85 @@
           </a:bodyPr>
           <a:lstStyle/>
           <a:p>
-            <a:pPr algn="ctr"/>
-            <a:r>
-              <a:rPr sz="1400" b="0" i="0">
-                <a:solidFill>
-                  <a:srgbClr val="504E49"/>
+            <a:pPr algn="l"/>
+            <a:r>
+              <a:rPr sz="1700" b="0" i="0">
+                <a:solidFill>
+                  <a:srgbClr val="3D3D3A"/>
                 </a:solidFill>
                 <a:latin typeface="Charter"/>
               </a:rPr>
-              <a:t>Verdicts traceable to source</a:t>
+              <a:t>Apply invites are token-hashed, single-use, expiring</a:t>
+            </a:r>
+          </a:p>
+        </p:txBody>
+      </p:sp>
+      <p:sp>
+        <p:nvSpPr>
+          <p:cNvPr id="15" name="TextBox 14"/>
+          <p:cNvSpPr txBox="1"/>
+          <p:nvPr/>
+        </p:nvSpPr>
+        <p:spPr>
+          <a:xfrm>
+            <a:off x="6400800" y="4846320"/>
+            <a:ext cx="4754880" cy="640080"/>
+          </a:xfrm>
+          <a:prstGeom prst="rect">
+            <a:avLst/>
+          </a:prstGeom>
+          <a:noFill/>
+        </p:spPr>
+        <p:txBody>
+          <a:bodyPr wrap="square" lIns="0" tIns="0" rIns="0" bIns="0" anchor="t">
+            <a:spAutoFit/>
+          </a:bodyPr>
+          <a:lstStyle/>
+          <a:p>
+            <a:pPr algn="l"/>
+            <a:r>
+              <a:rPr sz="1700" b="0" i="0">
+                <a:solidFill>
+                  <a:srgbClr val="3D3D3A"/>
+                </a:solidFill>
+                <a:latin typeface="Charter"/>
+              </a:rPr>
+              <a:t>Adding a check is a definition file, not a retrain</a:t>
+            </a:r>
+          </a:p>
+        </p:txBody>
+      </p:sp>
+      <p:sp>
+        <p:nvSpPr>
+          <p:cNvPr id="16" name="TextBox 15"/>
+          <p:cNvSpPr txBox="1"/>
+          <p:nvPr/>
+        </p:nvSpPr>
+        <p:spPr>
+          <a:xfrm>
+            <a:off x="10515600" y="6309360"/>
+            <a:ext cx="1371600" cy="274320"/>
+          </a:xfrm>
+          <a:prstGeom prst="rect">
+            <a:avLst/>
+          </a:prstGeom>
+          <a:noFill/>
+        </p:spPr>
+        <p:txBody>
+          <a:bodyPr wrap="square" lIns="0" tIns="0" rIns="0" bIns="0" anchor="t">
+            <a:spAutoFit/>
+          </a:bodyPr>
+          <a:lstStyle/>
+          <a:p>
+            <a:pPr algn="r"/>
+            <a:r>
+              <a:rPr sz="1100" b="0" i="0">
+                <a:solidFill>
+                  <a:srgbClr val="6B6A64"/>
+                </a:solidFill>
+                <a:latin typeface="Charter"/>
+              </a:rPr>
+              <a:t> - 05</a:t>
             </a:r>
           </a:p>
         </p:txBody>
@@ -5178,8 +5205,8 @@
         </p:nvSpPr>
         <p:spPr>
           <a:xfrm>
-            <a:off x="914400" y="2743200"/>
-            <a:ext cx="10360152" cy="677108"/>
+            <a:off x="1097280" y="548640"/>
+            <a:ext cx="9144000" cy="365760"/>
           </a:xfrm>
           <a:prstGeom prst="rect">
             <a:avLst/>
@@ -5192,42 +5219,225 @@
           </a:bodyPr>
           <a:lstStyle/>
           <a:p>
-            <a:pPr algn="ctr"/>
-            <a:r>
-              <a:rPr sz="4400" b="0" i="0" dirty="0">
-                <a:solidFill>
-                  <a:srgbClr val="141413"/>
+            <a:pPr algn="l"/>
+            <a:r>
+              <a:rPr sz="1100" b="0" i="0">
+                <a:solidFill>
+                  <a:srgbClr val="6B6A64"/>
                 </a:solidFill>
                 <a:latin typeface="Charter"/>
               </a:rPr>
-              <a:t>Fewer tabs. </a:t>
-            </a:r>
-            <a:r>
-              <a:rPr lang="en-AU" sz="4400" b="0" i="0" dirty="0">
+              <a:t>05  ·  DEPLOYMENT</a:t>
+            </a:r>
+          </a:p>
+        </p:txBody>
+      </p:sp>
+      <p:sp>
+        <p:nvSpPr>
+          <p:cNvPr id="4" name="TextBox 3"/>
+          <p:cNvSpPr txBox="1"/>
+          <p:nvPr/>
+        </p:nvSpPr>
+        <p:spPr>
+          <a:xfrm>
+            <a:off x="1097280" y="1097280"/>
+            <a:ext cx="10360152" cy="1097280"/>
+          </a:xfrm>
+          <a:prstGeom prst="rect">
+            <a:avLst/>
+          </a:prstGeom>
+          <a:noFill/>
+        </p:spPr>
+        <p:txBody>
+          <a:bodyPr wrap="square" lIns="0" tIns="0" rIns="0" bIns="0" anchor="t">
+            <a:spAutoFit/>
+          </a:bodyPr>
+          <a:lstStyle/>
+          <a:p>
+            <a:pPr algn="l"/>
+            <a:r>
+              <a:rPr sz="3400" b="0" i="0">
                 <a:solidFill>
                   <a:srgbClr val="141413"/>
                 </a:solidFill>
                 <a:latin typeface="Charter"/>
               </a:rPr>
-              <a:t>Data rich </a:t>
-            </a:r>
-            <a:r>
-              <a:rPr lang="en-AU" sz="4400" dirty="0">
-                <a:solidFill>
-                  <a:srgbClr val="141413"/>
+              <a:t>Replaces three tools with one loop.</a:t>
+            </a:r>
+          </a:p>
+        </p:txBody>
+      </p:sp>
+      <p:sp>
+        <p:nvSpPr>
+          <p:cNvPr id="5" name="TextBox 4"/>
+          <p:cNvSpPr txBox="1"/>
+          <p:nvPr/>
+        </p:nvSpPr>
+        <p:spPr>
+          <a:xfrm>
+            <a:off x="1097280" y="2743200"/>
+            <a:ext cx="10058400" cy="3200400"/>
+          </a:xfrm>
+          <a:prstGeom prst="rect">
+            <a:avLst/>
+          </a:prstGeom>
+          <a:noFill/>
+        </p:spPr>
+        <p:txBody>
+          <a:bodyPr wrap="square" lIns="0" tIns="0" rIns="0" bIns="0" anchor="t">
+            <a:spAutoFit/>
+          </a:bodyPr>
+          <a:lstStyle/>
+          <a:p>
+            <a:pPr algn="l"/>
+            <a:r>
+              <a:rPr sz="1800" b="0" i="0">
+                <a:solidFill>
+                  <a:srgbClr val="3D3D3A"/>
                 </a:solidFill>
                 <a:latin typeface="Charter"/>
               </a:rPr>
-              <a:t>memo</a:t>
-            </a:r>
-            <a:r>
-              <a:rPr sz="4400" b="0" i="0" dirty="0">
-                <a:solidFill>
-                  <a:srgbClr val="141413"/>
+              <a:t>Founder intake form, market intelligence subscription, IC memo template — Capital collapses all three into a single state machine your team already knows how to read. Runs at prod volumes today. Your check library imports in a day, your /apply page is brandable, watch targets are configurable per deal — pin a customer page, an X account, anything that signals truth.</a:t>
+            </a:r>
+          </a:p>
+        </p:txBody>
+      </p:sp>
+      <p:sp>
+        <p:nvSpPr>
+          <p:cNvPr id="6" name="TextBox 5"/>
+          <p:cNvSpPr txBox="1"/>
+          <p:nvPr/>
+        </p:nvSpPr>
+        <p:spPr>
+          <a:xfrm>
+            <a:off x="10515600" y="6309360"/>
+            <a:ext cx="1371600" cy="274320"/>
+          </a:xfrm>
+          <a:prstGeom prst="rect">
+            <a:avLst/>
+          </a:prstGeom>
+          <a:noFill/>
+        </p:spPr>
+        <p:txBody>
+          <a:bodyPr wrap="square" lIns="0" tIns="0" rIns="0" bIns="0" anchor="t">
+            <a:spAutoFit/>
+          </a:bodyPr>
+          <a:lstStyle/>
+          <a:p>
+            <a:pPr algn="r"/>
+            <a:r>
+              <a:rPr sz="1100" b="0" i="0">
+                <a:solidFill>
+                  <a:srgbClr val="6B6A64"/>
                 </a:solidFill>
                 <a:latin typeface="Charter"/>
               </a:rPr>
-              <a:t>.</a:t>
+              <a:t> - 06</a:t>
+            </a:r>
+          </a:p>
+        </p:txBody>
+      </p:sp>
+    </p:spTree>
+  </p:cSld>
+  <p:clrMapOvr>
+    <a:masterClrMapping/>
+  </p:clrMapOvr>
+</p:sld>
+</file>
+
+<file path=ppt/slides/slide7.xml><?xml version="1.0" encoding="utf-8"?>
+<p:sld xmlns:a="http://schemas.openxmlformats.org/drawingml/2006/main" xmlns:r="http://schemas.openxmlformats.org/officeDocument/2006/relationships" xmlns:p="http://schemas.openxmlformats.org/presentationml/2006/main">
+  <p:cSld>
+    <p:spTree>
+      <p:nvGrpSpPr>
+        <p:cNvPr id="1" name=""/>
+        <p:cNvGrpSpPr/>
+        <p:nvPr/>
+      </p:nvGrpSpPr>
+      <p:grpSpPr>
+        <a:xfrm>
+          <a:off x="0" y="0"/>
+          <a:ext cx="0" cy="0"/>
+          <a:chOff x="0" y="0"/>
+          <a:chExt cx="0" cy="0"/>
+        </a:xfrm>
+      </p:grpSpPr>
+      <p:sp>
+        <p:nvSpPr>
+          <p:cNvPr id="2" name="Rectangle 1"/>
+          <p:cNvSpPr/>
+          <p:nvPr/>
+        </p:nvSpPr>
+        <p:spPr>
+          <a:xfrm>
+            <a:off x="0" y="0"/>
+            <a:ext cx="12188952" cy="6858000"/>
+          </a:xfrm>
+          <a:prstGeom prst="rect">
+            <a:avLst/>
+          </a:prstGeom>
+          <a:solidFill>
+            <a:srgbClr val="F5F4ED"/>
+          </a:solidFill>
+          <a:ln>
+            <a:noFill/>
+          </a:ln>
+          <a:effectLst/>
+        </p:spPr>
+        <p:style>
+          <a:lnRef idx="1">
+            <a:schemeClr val="accent1"/>
+          </a:lnRef>
+          <a:fillRef idx="3">
+            <a:schemeClr val="accent1"/>
+          </a:fillRef>
+          <a:effectRef idx="2">
+            <a:schemeClr val="accent1"/>
+          </a:effectRef>
+          <a:fontRef idx="minor">
+            <a:schemeClr val="lt1"/>
+          </a:fontRef>
+        </p:style>
+        <p:txBody>
+          <a:bodyPr rtlCol="0" anchor="ctr"/>
+          <a:lstStyle/>
+          <a:p>
+            <a:pPr algn="ctr"/>
+            <a:endParaRPr/>
+          </a:p>
+        </p:txBody>
+      </p:sp>
+      <p:sp>
+        <p:nvSpPr>
+          <p:cNvPr id="3" name="TextBox 2"/>
+          <p:cNvSpPr txBox="1"/>
+          <p:nvPr/>
+        </p:nvSpPr>
+        <p:spPr>
+          <a:xfrm>
+            <a:off x="914400" y="2743200"/>
+            <a:ext cx="10360152" cy="1097280"/>
+          </a:xfrm>
+          <a:prstGeom prst="rect">
+            <a:avLst/>
+          </a:prstGeom>
+          <a:noFill/>
+        </p:spPr>
+        <p:txBody>
+          <a:bodyPr wrap="square" lIns="0" tIns="0" rIns="0" bIns="0" anchor="t">
+            <a:spAutoFit/>
+          </a:bodyPr>
+          <a:lstStyle/>
+          <a:p>
+            <a:pPr algn="ctr"/>
+            <a:r>
+              <a:rPr sz="4400" b="0" i="0">
+                <a:solidFill>
+                  <a:srgbClr val="141413"/>
+                </a:solidFill>
+                <a:latin typeface="Charter"/>
+              </a:rPr>
+              <a:t>Pilot Capital on 10 live deals from your pipeline.</a:t>
             </a:r>
           </a:p>
         </p:txBody>
@@ -5267,74 +5477,6 @@
           </a:fontRef>
         </p:style>
       </p:cxnSp>
-      <p:sp>
-        <p:nvSpPr>
-          <p:cNvPr id="5" name="TextBox 4"/>
-          <p:cNvSpPr txBox="1"/>
-          <p:nvPr/>
-        </p:nvSpPr>
-        <p:spPr>
-          <a:xfrm>
-            <a:off x="914400" y="4389120"/>
-            <a:ext cx="10360152" cy="246221"/>
-          </a:xfrm>
-          <a:prstGeom prst="rect">
-            <a:avLst/>
-          </a:prstGeom>
-          <a:noFill/>
-        </p:spPr>
-        <p:txBody>
-          <a:bodyPr wrap="square" lIns="0" tIns="0" rIns="0" bIns="0" anchor="t">
-            <a:spAutoFit/>
-          </a:bodyPr>
-          <a:lstStyle/>
-          <a:p>
-            <a:pPr algn="ctr"/>
-            <a:r>
-              <a:rPr sz="1600" b="0" i="0" dirty="0">
-                <a:solidFill>
-                  <a:srgbClr val="504E49"/>
-                </a:solidFill>
-                <a:latin typeface="Charter"/>
-              </a:rPr>
-              <a:t>Live</a:t>
-            </a:r>
-            <a:r>
-              <a:rPr lang="en-AU" sz="1600" dirty="0">
-                <a:solidFill>
-                  <a:srgbClr val="504E49"/>
-                </a:solidFill>
-                <a:latin typeface="Charter"/>
-              </a:rPr>
-              <a:t> @</a:t>
-            </a:r>
-            <a:r>
-              <a:rPr lang="en-AU" sz="1600" b="0" i="0" dirty="0">
-                <a:solidFill>
-                  <a:srgbClr val="504E49"/>
-                </a:solidFill>
-                <a:latin typeface="Charter"/>
-              </a:rPr>
-              <a:t> https://</a:t>
-            </a:r>
-            <a:r>
-              <a:rPr lang="en-AU" sz="1600" b="0" i="0" dirty="0" err="1">
-                <a:solidFill>
-                  <a:srgbClr val="504E49"/>
-                </a:solidFill>
-                <a:latin typeface="Charter"/>
-              </a:rPr>
-              <a:t>capital.kndwin.dev</a:t>
-            </a:r>
-            <a:endParaRPr sz="1600" b="0" i="0" dirty="0">
-              <a:solidFill>
-                <a:srgbClr val="504E49"/>
-              </a:solidFill>
-              <a:latin typeface="Charter"/>
-            </a:endParaRPr>
-          </a:p>
-        </p:txBody>
-      </p:sp>
     </p:spTree>
   </p:cSld>
   <p:clrMapOvr>

</xml_diff>